<commit_message>
class dicts with decorator factories, duplicate check config: dataclass + YAML loader with dotted-path CLI overrides training: make_run_dir anchored to RUNS_DIR (idempotent) scripts/train.py: argparse entry point (--config, -o/--override, --resume) tests: smoke suite asserting contracts, not hyperparameter values gitignore: anchor data/ to repo root so potlab/data/ stays trackable docs: flat-layout updates + batch_size_eval rename
</commit_message>
<xml_diff>
--- a/docs/painn.pptx
+++ b/docs/painn.pptx
@@ -106,6 +106,11 @@
       </a:defRPr>
     </a:lvl9pPr>
   </p:defaultTextStyle>
+  <p:extLst>
+    <p:ext uri="{EFAFB233-063F-42B5-8137-9DF3F51BA10A}">
+      <p15:sldGuideLst xmlns:p15="http://schemas.microsoft.com/office/powerpoint/2012/main"/>
+    </p:ext>
+  </p:extLst>
 </p:presentation>
 </file>
 
@@ -268,7 +273,7 @@
           <a:p>
             <a:fld id="{53EF0FDD-2F79-4291-8E61-F81F3449F154}" type="datetimeFigureOut">
               <a:rPr lang="zh-CN" altLang="en-US" smtClean="0"/>
-              <a:t>2026/8/17</a:t>
+              <a:t>2026/8/18</a:t>
             </a:fld>
             <a:endParaRPr lang="zh-CN" altLang="en-US"/>
           </a:p>
@@ -466,7 +471,7 @@
           <a:p>
             <a:fld id="{53EF0FDD-2F79-4291-8E61-F81F3449F154}" type="datetimeFigureOut">
               <a:rPr lang="zh-CN" altLang="en-US" smtClean="0"/>
-              <a:t>2026/8/17</a:t>
+              <a:t>2026/8/18</a:t>
             </a:fld>
             <a:endParaRPr lang="zh-CN" altLang="en-US"/>
           </a:p>
@@ -674,7 +679,7 @@
           <a:p>
             <a:fld id="{53EF0FDD-2F79-4291-8E61-F81F3449F154}" type="datetimeFigureOut">
               <a:rPr lang="zh-CN" altLang="en-US" smtClean="0"/>
-              <a:t>2026/8/17</a:t>
+              <a:t>2026/8/18</a:t>
             </a:fld>
             <a:endParaRPr lang="zh-CN" altLang="en-US"/>
           </a:p>
@@ -872,7 +877,7 @@
           <a:p>
             <a:fld id="{53EF0FDD-2F79-4291-8E61-F81F3449F154}" type="datetimeFigureOut">
               <a:rPr lang="zh-CN" altLang="en-US" smtClean="0"/>
-              <a:t>2026/8/17</a:t>
+              <a:t>2026/8/18</a:t>
             </a:fld>
             <a:endParaRPr lang="zh-CN" altLang="en-US"/>
           </a:p>
@@ -1147,7 +1152,7 @@
           <a:p>
             <a:fld id="{53EF0FDD-2F79-4291-8E61-F81F3449F154}" type="datetimeFigureOut">
               <a:rPr lang="zh-CN" altLang="en-US" smtClean="0"/>
-              <a:t>2026/8/17</a:t>
+              <a:t>2026/8/18</a:t>
             </a:fld>
             <a:endParaRPr lang="zh-CN" altLang="en-US"/>
           </a:p>
@@ -1412,7 +1417,7 @@
           <a:p>
             <a:fld id="{53EF0FDD-2F79-4291-8E61-F81F3449F154}" type="datetimeFigureOut">
               <a:rPr lang="zh-CN" altLang="en-US" smtClean="0"/>
-              <a:t>2026/8/17</a:t>
+              <a:t>2026/8/18</a:t>
             </a:fld>
             <a:endParaRPr lang="zh-CN" altLang="en-US"/>
           </a:p>
@@ -1824,7 +1829,7 @@
           <a:p>
             <a:fld id="{53EF0FDD-2F79-4291-8E61-F81F3449F154}" type="datetimeFigureOut">
               <a:rPr lang="zh-CN" altLang="en-US" smtClean="0"/>
-              <a:t>2026/8/17</a:t>
+              <a:t>2026/8/18</a:t>
             </a:fld>
             <a:endParaRPr lang="zh-CN" altLang="en-US"/>
           </a:p>
@@ -1965,7 +1970,7 @@
           <a:p>
             <a:fld id="{53EF0FDD-2F79-4291-8E61-F81F3449F154}" type="datetimeFigureOut">
               <a:rPr lang="zh-CN" altLang="en-US" smtClean="0"/>
-              <a:t>2026/8/17</a:t>
+              <a:t>2026/8/18</a:t>
             </a:fld>
             <a:endParaRPr lang="zh-CN" altLang="en-US"/>
           </a:p>
@@ -2078,7 +2083,7 @@
           <a:p>
             <a:fld id="{53EF0FDD-2F79-4291-8E61-F81F3449F154}" type="datetimeFigureOut">
               <a:rPr lang="zh-CN" altLang="en-US" smtClean="0"/>
-              <a:t>2026/8/17</a:t>
+              <a:t>2026/8/18</a:t>
             </a:fld>
             <a:endParaRPr lang="zh-CN" altLang="en-US"/>
           </a:p>
@@ -2389,7 +2394,7 @@
           <a:p>
             <a:fld id="{53EF0FDD-2F79-4291-8E61-F81F3449F154}" type="datetimeFigureOut">
               <a:rPr lang="zh-CN" altLang="en-US" smtClean="0"/>
-              <a:t>2026/8/17</a:t>
+              <a:t>2026/8/18</a:t>
             </a:fld>
             <a:endParaRPr lang="zh-CN" altLang="en-US"/>
           </a:p>
@@ -2677,7 +2682,7 @@
           <a:p>
             <a:fld id="{53EF0FDD-2F79-4291-8E61-F81F3449F154}" type="datetimeFigureOut">
               <a:rPr lang="zh-CN" altLang="en-US" smtClean="0"/>
-              <a:t>2026/8/17</a:t>
+              <a:t>2026/8/18</a:t>
             </a:fld>
             <a:endParaRPr lang="zh-CN" altLang="en-US"/>
           </a:p>
@@ -2918,7 +2923,7 @@
           <a:p>
             <a:fld id="{53EF0FDD-2F79-4291-8E61-F81F3449F154}" type="datetimeFigureOut">
               <a:rPr lang="zh-CN" altLang="en-US" smtClean="0"/>
-              <a:t>2026/8/17</a:t>
+              <a:t>2026/8/18</a:t>
             </a:fld>
             <a:endParaRPr lang="zh-CN" altLang="en-US"/>
           </a:p>
@@ -4662,7 +4667,7 @@
         <p:spPr>
           <a:xfrm>
             <a:off x="1571153" y="950769"/>
-            <a:ext cx="6904454" cy="369332"/>
+            <a:ext cx="6615914" cy="369332"/>
           </a:xfrm>
           <a:prstGeom prst="rect">
             <a:avLst/>
@@ -4676,12 +4681,20 @@
           <a:lstStyle/>
           <a:p>
             <a:r>
-              <a:rPr lang="zh-CN" altLang="en-US" b="1" dirty="0">
+              <a:rPr lang="en-US" altLang="zh-CN" b="1">
                 <a:solidFill>
                   <a:srgbClr val="FF0000"/>
                 </a:solidFill>
               </a:rPr>
-              <a:t>复现目标：</a:t>
+              <a:t>target</a:t>
+            </a:r>
+            <a:r>
+              <a:rPr lang="zh-CN" altLang="en-US" b="1">
+                <a:solidFill>
+                  <a:srgbClr val="FF0000"/>
+                </a:solidFill>
+              </a:rPr>
+              <a:t>：</a:t>
             </a:r>
             <a:r>
               <a:rPr lang="en-US" altLang="zh-CN" b="1" dirty="0">

</xml_diff>